<commit_message>
add week 24 slides
</commit_message>
<xml_diff>
--- a/slides/week-23-paige.pptx
+++ b/slides/week-23-paige.pptx
@@ -39,7 +39,7 @@
     <p:sldId id="321" r:id="rId27"/>
     <p:sldId id="344" r:id="rId28"/>
     <p:sldId id="345" r:id="rId29"/>
-    <p:sldId id="346" r:id="rId30"/>
+    <p:sldId id="365" r:id="rId30"/>
     <p:sldId id="323" r:id="rId31"/>
     <p:sldId id="328" r:id="rId32"/>
     <p:sldId id="329" r:id="rId33"/>
@@ -325,7 +325,7 @@
               <a:pPr>
                 <a:defRPr/>
               </a:pPr>
-              <a:t>5/29/26</a:t>
+              <a:t>6/9/26</a:t>
             </a:fld>
             <a:endParaRPr lang="en-US"/>
           </a:p>
@@ -4044,7 +4044,7 @@
               <a:pPr>
                 <a:defRPr/>
               </a:pPr>
-              <a:t>5/29/26</a:t>
+              <a:t>6/9/26</a:t>
             </a:fld>
             <a:endParaRPr lang="en-US" altLang="en-US"/>
           </a:p>
@@ -13268,247 +13268,6 @@
           </a:p>
         </p:txBody>
       </p:sp>
-      <p:sp>
-        <p:nvSpPr>
-          <p:cNvPr id="6" name="Rounded Rectangle 5">
-            <a:extLst>
-              <a:ext uri="{FF2B5EF4-FFF2-40B4-BE49-F238E27FC236}">
-                <a16:creationId xmlns:a16="http://schemas.microsoft.com/office/drawing/2014/main" id="{9A8552CB-553D-AFE1-B354-C025994F34BB}"/>
-              </a:ext>
-            </a:extLst>
-          </p:cNvPr>
-          <p:cNvSpPr/>
-          <p:nvPr/>
-        </p:nvSpPr>
-        <p:spPr>
-          <a:xfrm>
-            <a:off x="6724580" y="3564262"/>
-            <a:ext cx="2247900" cy="1294364"/>
-          </a:xfrm>
-          <a:prstGeom prst="roundRect">
-            <a:avLst>
-              <a:gd name="adj" fmla="val 19866"/>
-            </a:avLst>
-          </a:prstGeom>
-          <a:solidFill>
-            <a:srgbClr val="FFC000">
-              <a:alpha val="25000"/>
-            </a:srgbClr>
-          </a:solidFill>
-          <a:ln>
-            <a:solidFill>
-              <a:srgbClr val="FFC000"/>
-            </a:solidFill>
-          </a:ln>
-        </p:spPr>
-        <p:style>
-          <a:lnRef idx="2">
-            <a:schemeClr val="accent1">
-              <a:shade val="50000"/>
-            </a:schemeClr>
-          </a:lnRef>
-          <a:fillRef idx="1">
-            <a:schemeClr val="accent1"/>
-          </a:fillRef>
-          <a:effectRef idx="0">
-            <a:schemeClr val="accent1"/>
-          </a:effectRef>
-          <a:fontRef idx="minor">
-            <a:schemeClr val="lt1"/>
-          </a:fontRef>
-        </p:style>
-        <p:txBody>
-          <a:bodyPr rtlCol="0" anchor="ctr"/>
-          <a:lstStyle/>
-          <a:p>
-            <a:r>
-              <a:rPr lang="en-US" sz="1000" dirty="0">
-                <a:solidFill>
-                  <a:schemeClr val="tx1"/>
-                </a:solidFill>
-              </a:rPr>
-              <a:t>P </a:t>
-            </a:r>
-            <a:r>
-              <a:rPr lang="en-US" sz="1000" dirty="0">
-                <a:solidFill>
-                  <a:schemeClr val="tx1"/>
-                </a:solidFill>
-                <a:sym typeface="Symbol"/>
-              </a:rPr>
-              <a:t> I</a:t>
-            </a:r>
-            <a:br>
-              <a:rPr lang="en-US" sz="1000" dirty="0">
-                <a:solidFill>
-                  <a:schemeClr val="tx1"/>
-                </a:solidFill>
-                <a:sym typeface="Symbol"/>
-              </a:rPr>
-            </a:br>
-            <a:r>
-              <a:rPr lang="en-US" sz="1000" dirty="0">
-                <a:solidFill>
-                  <a:schemeClr val="tx1"/>
-                </a:solidFill>
-                <a:sym typeface="Symbol"/>
-              </a:rPr>
-              <a:t>{* g  /\  I *}    S    {*  I  *}</a:t>
-            </a:r>
-            <a:br>
-              <a:rPr lang="en-US" sz="1000" dirty="0">
-                <a:solidFill>
-                  <a:schemeClr val="tx1"/>
-                </a:solidFill>
-                <a:sym typeface="Symbol"/>
-              </a:rPr>
-            </a:br>
-            <a:r>
-              <a:rPr lang="en-US" sz="1000" dirty="0">
-                <a:solidFill>
-                  <a:schemeClr val="tx1"/>
-                </a:solidFill>
-                <a:sym typeface="Symbol"/>
-              </a:rPr>
-              <a:t>I  /\ g    Q </a:t>
-            </a:r>
-            <a:br>
-              <a:rPr lang="en-US" sz="1000" dirty="0">
-                <a:solidFill>
-                  <a:schemeClr val="tx1"/>
-                </a:solidFill>
-                <a:sym typeface="Symbol"/>
-              </a:rPr>
-            </a:br>
-            <a:r>
-              <a:rPr lang="en-US" sz="1000" dirty="0">
-                <a:solidFill>
-                  <a:schemeClr val="tx1"/>
-                </a:solidFill>
-                <a:sym typeface="Symbol"/>
-              </a:rPr>
-              <a:t>{* I /\ g *}    C:=m; S   {* m&lt;C *} </a:t>
-            </a:r>
-            <a:br>
-              <a:rPr lang="en-US" sz="1000" dirty="0">
-                <a:solidFill>
-                  <a:schemeClr val="tx1"/>
-                </a:solidFill>
-                <a:sym typeface="Symbol"/>
-              </a:rPr>
-            </a:br>
-            <a:r>
-              <a:rPr lang="en-US" sz="1000" dirty="0">
-                <a:solidFill>
-                  <a:schemeClr val="tx1"/>
-                </a:solidFill>
-                <a:sym typeface="Symbol"/>
-              </a:rPr>
-              <a:t>I /\ g   </a:t>
-            </a:r>
-            <a:r>
-              <a:rPr lang="en-US" sz="1000" dirty="0">
-                <a:solidFill>
-                  <a:schemeClr val="tx1"/>
-                </a:solidFill>
-              </a:rPr>
-              <a:t>m </a:t>
-            </a:r>
-            <a:r>
-              <a:rPr lang="en-US" sz="1000" dirty="0">
-                <a:solidFill>
-                  <a:schemeClr val="tx1"/>
-                </a:solidFill>
-                <a:sym typeface="Symbol"/>
-              </a:rPr>
-              <a:t>&gt; 0</a:t>
-            </a:r>
-            <a:br>
-              <a:rPr lang="en-US" sz="1000" dirty="0">
-                <a:solidFill>
-                  <a:schemeClr val="tx1"/>
-                </a:solidFill>
-                <a:sym typeface="Symbol"/>
-              </a:rPr>
-            </a:br>
-            <a:r>
-              <a:rPr lang="en-US" sz="1000" dirty="0">
-                <a:solidFill>
-                  <a:schemeClr val="tx1"/>
-                </a:solidFill>
-                <a:sym typeface="Symbol"/>
-              </a:rPr>
-              <a:t>----------------------------------------</a:t>
-            </a:r>
-            <a:br>
-              <a:rPr lang="en-US" sz="1000" dirty="0">
-                <a:solidFill>
-                  <a:schemeClr val="tx1"/>
-                </a:solidFill>
-                <a:sym typeface="Symbol"/>
-              </a:rPr>
-            </a:br>
-            <a:r>
-              <a:rPr lang="en-US" sz="1000" dirty="0">
-                <a:solidFill>
-                  <a:schemeClr val="tx1"/>
-                </a:solidFill>
-                <a:sym typeface="Symbol"/>
-              </a:rPr>
-              <a:t>{* P *}   </a:t>
-            </a:r>
-            <a:r>
-              <a:rPr lang="en-US" sz="1000" b="1" dirty="0">
-                <a:solidFill>
-                  <a:schemeClr val="tx1"/>
-                </a:solidFill>
-                <a:sym typeface="Symbol"/>
-              </a:rPr>
-              <a:t>while</a:t>
-            </a:r>
-            <a:r>
-              <a:rPr lang="en-US" sz="1000" dirty="0">
-                <a:solidFill>
-                  <a:schemeClr val="tx1"/>
-                </a:solidFill>
-                <a:sym typeface="Symbol"/>
-              </a:rPr>
-              <a:t>  g  </a:t>
-            </a:r>
-            <a:r>
-              <a:rPr lang="en-US" sz="1000" b="1" dirty="0">
-                <a:solidFill>
-                  <a:schemeClr val="tx1"/>
-                </a:solidFill>
-                <a:sym typeface="Symbol"/>
-              </a:rPr>
-              <a:t>do</a:t>
-            </a:r>
-            <a:r>
-              <a:rPr lang="en-US" sz="1000" dirty="0">
-                <a:solidFill>
-                  <a:schemeClr val="tx1"/>
-                </a:solidFill>
-                <a:sym typeface="Symbol"/>
-              </a:rPr>
-              <a:t>   S    {* Q *}</a:t>
-            </a:r>
-            <a:br>
-              <a:rPr lang="en-US" sz="1000" dirty="0">
-                <a:solidFill>
-                  <a:schemeClr val="tx1"/>
-                </a:solidFill>
-                <a:sym typeface="Symbol"/>
-              </a:rPr>
-            </a:br>
-            <a:endParaRPr lang="en-US" sz="1000" dirty="0">
-              <a:solidFill>
-                <a:schemeClr val="tx1"/>
-              </a:solidFill>
-            </a:endParaRPr>
-          </a:p>
-        </p:txBody>
-      </p:sp>
     </p:spTree>
   </p:cSld>
   <p:clrMapOvr>
@@ -13648,51 +13407,6 @@
                       </p:childTnLst>
                     </p:cTn>
                   </p:par>
-                  <p:par>
-                    <p:cTn id="13" fill="hold">
-                      <p:stCondLst>
-                        <p:cond delay="indefinite"/>
-                      </p:stCondLst>
-                      <p:childTnLst>
-                        <p:par>
-                          <p:cTn id="14" fill="hold">
-                            <p:stCondLst>
-                              <p:cond delay="0"/>
-                            </p:stCondLst>
-                            <p:childTnLst>
-                              <p:par>
-                                <p:cTn id="15" presetID="1" presetClass="entr" presetSubtype="0" fill="hold" grpId="0" nodeType="clickEffect">
-                                  <p:stCondLst>
-                                    <p:cond delay="0"/>
-                                  </p:stCondLst>
-                                  <p:childTnLst>
-                                    <p:set>
-                                      <p:cBhvr>
-                                        <p:cTn id="16" dur="1" fill="hold">
-                                          <p:stCondLst>
-                                            <p:cond delay="0"/>
-                                          </p:stCondLst>
-                                        </p:cTn>
-                                        <p:tgtEl>
-                                          <p:spTgt spid="6"/>
-                                        </p:tgtEl>
-                                        <p:attrNameLst>
-                                          <p:attrName>style.visibility</p:attrName>
-                                        </p:attrNameLst>
-                                      </p:cBhvr>
-                                      <p:to>
-                                        <p:strVal val="visible"/>
-                                      </p:to>
-                                    </p:set>
-                                  </p:childTnLst>
-                                </p:cTn>
-                              </p:par>
-                            </p:childTnLst>
-                          </p:cTn>
-                        </p:par>
-                      </p:childTnLst>
-                    </p:cTn>
-                  </p:par>
                 </p:childTnLst>
               </p:cTn>
               <p:prevCondLst>
@@ -13719,7 +13433,6 @@
       <p:bldP spid="8" grpId="0"/>
       <p:bldP spid="10" grpId="0" animBg="1"/>
       <p:bldP spid="11" grpId="0" animBg="1"/>
-      <p:bldP spid="6" grpId="0" animBg="1"/>
     </p:bldLst>
   </p:timing>
 </p:sld>
@@ -14877,6 +14590,9 @@
                     <p:cTn id="3" fill="hold">
                       <p:stCondLst>
                         <p:cond delay="indefinite"/>
+                        <p:cond evt="onBegin" delay="0">
+                          <p:tn val="2"/>
+                        </p:cond>
                       </p:stCondLst>
                       <p:childTnLst>
                         <p:par>
@@ -14886,7 +14602,7 @@
                             </p:stCondLst>
                             <p:childTnLst>
                               <p:par>
-                                <p:cTn id="5" presetID="1" presetClass="entr" presetSubtype="0" fill="hold" grpId="0" nodeType="clickEffect">
+                                <p:cTn id="5" presetID="1" presetClass="entr" presetSubtype="0" fill="hold" grpId="0" nodeType="withEffect">
                                   <p:stCondLst>
                                     <p:cond delay="0"/>
                                   </p:stCondLst>
@@ -14899,7 +14615,7 @@
                                           </p:stCondLst>
                                         </p:cTn>
                                         <p:tgtEl>
-                                          <p:spTgt spid="7"/>
+                                          <p:spTgt spid="10"/>
                                         </p:tgtEl>
                                         <p:attrNameLst>
                                           <p:attrName>style.visibility</p:attrName>
@@ -14926,60 +14642,6 @@
                                           </p:stCondLst>
                                         </p:cTn>
                                         <p:tgtEl>
-                                          <p:spTgt spid="8"/>
-                                        </p:tgtEl>
-                                        <p:attrNameLst>
-                                          <p:attrName>style.visibility</p:attrName>
-                                        </p:attrNameLst>
-                                      </p:cBhvr>
-                                      <p:to>
-                                        <p:strVal val="visible"/>
-                                      </p:to>
-                                    </p:set>
-                                  </p:childTnLst>
-                                </p:cTn>
-                              </p:par>
-                              <p:par>
-                                <p:cTn id="9" presetID="1" presetClass="entr" presetSubtype="0" fill="hold" grpId="0" nodeType="withEffect">
-                                  <p:stCondLst>
-                                    <p:cond delay="0"/>
-                                  </p:stCondLst>
-                                  <p:childTnLst>
-                                    <p:set>
-                                      <p:cBhvr>
-                                        <p:cTn id="10" dur="1" fill="hold">
-                                          <p:stCondLst>
-                                            <p:cond delay="0"/>
-                                          </p:stCondLst>
-                                        </p:cTn>
-                                        <p:tgtEl>
-                                          <p:spTgt spid="10"/>
-                                        </p:tgtEl>
-                                        <p:attrNameLst>
-                                          <p:attrName>style.visibility</p:attrName>
-                                        </p:attrNameLst>
-                                      </p:cBhvr>
-                                      <p:to>
-                                        <p:strVal val="visible"/>
-                                      </p:to>
-                                    </p:set>
-                                  </p:childTnLst>
-                                </p:cTn>
-                              </p:par>
-                              <p:par>
-                                <p:cTn id="11" presetID="1" presetClass="entr" presetSubtype="0" fill="hold" grpId="0" nodeType="withEffect">
-                                  <p:stCondLst>
-                                    <p:cond delay="0"/>
-                                  </p:stCondLst>
-                                  <p:childTnLst>
-                                    <p:set>
-                                      <p:cBhvr>
-                                        <p:cTn id="12" dur="1" fill="hold">
-                                          <p:stCondLst>
-                                            <p:cond delay="0"/>
-                                          </p:stCondLst>
-                                        </p:cTn>
-                                        <p:tgtEl>
                                           <p:spTgt spid="11"/>
                                         </p:tgtEl>
                                         <p:attrNameLst>
@@ -15000,26 +14662,26 @@
                     </p:cTn>
                   </p:par>
                   <p:par>
-                    <p:cTn id="13" fill="hold">
+                    <p:cTn id="9" fill="hold">
                       <p:stCondLst>
                         <p:cond delay="indefinite"/>
                       </p:stCondLst>
                       <p:childTnLst>
                         <p:par>
-                          <p:cTn id="14" fill="hold">
+                          <p:cTn id="10" fill="hold">
                             <p:stCondLst>
                               <p:cond delay="0"/>
                             </p:stCondLst>
                             <p:childTnLst>
                               <p:par>
-                                <p:cTn id="15" presetID="1" presetClass="entr" presetSubtype="0" fill="hold" grpId="0" nodeType="clickEffect">
+                                <p:cTn id="11" presetID="1" presetClass="entr" presetSubtype="0" fill="hold" grpId="0" nodeType="clickEffect">
                                   <p:stCondLst>
                                     <p:cond delay="0"/>
                                   </p:stCondLst>
                                   <p:childTnLst>
                                     <p:set>
                                       <p:cBhvr>
-                                        <p:cTn id="16" dur="1" fill="hold">
+                                        <p:cTn id="12" dur="1" fill="hold">
                                           <p:stCondLst>
                                             <p:cond delay="0"/>
                                           </p:stCondLst>
@@ -15039,14 +14701,14 @@
                                 </p:cTn>
                               </p:par>
                               <p:par>
-                                <p:cTn id="17" presetID="1" presetClass="entr" presetSubtype="0" fill="hold" nodeType="withEffect">
+                                <p:cTn id="13" presetID="1" presetClass="entr" presetSubtype="0" fill="hold" nodeType="withEffect">
                                   <p:stCondLst>
                                     <p:cond delay="0"/>
                                   </p:stCondLst>
                                   <p:childTnLst>
                                     <p:set>
                                       <p:cBhvr>
-                                        <p:cTn id="18" dur="1" fill="hold">
+                                        <p:cTn id="14" dur="1" fill="hold">
                                           <p:stCondLst>
                                             <p:cond delay="0"/>
                                           </p:stCondLst>
@@ -15066,14 +14728,14 @@
                                 </p:cTn>
                               </p:par>
                               <p:par>
-                                <p:cTn id="19" presetID="1" presetClass="entr" presetSubtype="0" fill="hold" grpId="0" nodeType="withEffect">
+                                <p:cTn id="15" presetID="1" presetClass="entr" presetSubtype="0" fill="hold" grpId="0" nodeType="withEffect">
                                   <p:stCondLst>
                                     <p:cond delay="0"/>
                                   </p:stCondLst>
                                   <p:childTnLst>
                                     <p:set>
                                       <p:cBhvr>
-                                        <p:cTn id="20" dur="1" fill="hold">
+                                        <p:cTn id="16" dur="1" fill="hold">
                                           <p:stCondLst>
                                             <p:cond delay="0"/>
                                           </p:stCondLst>
@@ -15120,8 +14782,6 @@
       </p:par>
     </p:tnLst>
     <p:bldLst>
-      <p:bldP spid="7" grpId="0"/>
-      <p:bldP spid="8" grpId="0"/>
       <p:bldP spid="10" grpId="0" animBg="1"/>
       <p:bldP spid="11" grpId="0" animBg="1"/>
       <p:bldP spid="6" grpId="0" animBg="1"/>
@@ -21390,7 +21050,7 @@
                 </a:solidFill>
                 <a:sym typeface="Symbol"/>
               </a:rPr>
-              <a:t>(I /\ g   m&gt;0)</a:t>
+              <a:t>(m&gt;0)</a:t>
             </a:r>
             <a:br>
               <a:rPr lang="en-US" sz="2000" dirty="0">
@@ -21517,7 +21177,7 @@
         </p:nvSpPr>
         <p:spPr>
           <a:xfrm>
-            <a:off x="5249297" y="2954804"/>
+            <a:off x="5249297" y="2459504"/>
             <a:ext cx="3456368" cy="1938992"/>
           </a:xfrm>
           <a:prstGeom prst="roundRect">
@@ -21575,8 +21235,8 @@
         </p:nvSpPr>
         <p:spPr>
           <a:xfrm>
-            <a:off x="7048500" y="3352801"/>
-            <a:ext cx="838200" cy="457200"/>
+            <a:off x="7048500" y="2857501"/>
+            <a:ext cx="571500" cy="457200"/>
           </a:xfrm>
           <a:prstGeom prst="roundRect">
             <a:avLst>
@@ -21631,7 +21291,7 @@
         </p:nvSpPr>
         <p:spPr>
           <a:xfrm>
-            <a:off x="609600" y="2954804"/>
+            <a:off x="609600" y="2459504"/>
             <a:ext cx="3208903" cy="1938992"/>
           </a:xfrm>
           <a:prstGeom prst="roundRect">
@@ -21741,7 +21401,7 @@
             </a:r>
             <a:r>
               <a:rPr lang="en-US" dirty="0"/>
-              <a:t>, but we can still look at the concept behind it, namely to stop a loop earlier because we know that it has achieved its objective. </a:t>
+              <a:t>, but we encode it in the guard.</a:t>
             </a:r>
           </a:p>
           <a:p>
@@ -21765,7 +21425,7 @@
           <a:p>
             <a:r>
               <a:rPr lang="en-US" dirty="0"/>
-              <a:t>How to prove that breaking the loop early is indeed safe?</a:t>
+              <a:t>How can we prove that breaking the loop early is indeed safe?</a:t>
             </a:r>
           </a:p>
         </p:txBody>
@@ -21854,7 +21514,7 @@
         </p:nvSpPr>
         <p:spPr bwMode="auto">
           <a:xfrm>
-            <a:off x="838200" y="2954804"/>
+            <a:off x="838200" y="2459504"/>
             <a:ext cx="2980303" cy="1938992"/>
           </a:xfrm>
           <a:prstGeom prst="rect">
@@ -21971,7 +21631,7 @@
         </p:nvSpPr>
         <p:spPr bwMode="auto">
           <a:xfrm>
-            <a:off x="5638800" y="2954804"/>
+            <a:off x="5638800" y="2459504"/>
             <a:ext cx="3066865" cy="1938992"/>
           </a:xfrm>
           <a:prstGeom prst="rect">
@@ -22032,7 +21692,7 @@
                   <a:srgbClr val="990033"/>
                 </a:solidFill>
               </a:rPr>
-              <a:t>/\ ¬r  </a:t>
+              <a:t>/\ r  </a:t>
             </a:r>
             <a:r>
               <a:rPr lang="en-US" sz="2400" b="1" dirty="0"/>
@@ -22094,7 +21754,7 @@
         </p:nvSpPr>
         <p:spPr>
           <a:xfrm>
-            <a:off x="4114800" y="3543300"/>
+            <a:off x="4114800" y="3048000"/>
             <a:ext cx="905897" cy="762000"/>
           </a:xfrm>
           <a:prstGeom prst="rightArrow">
@@ -22655,7 +22315,13 @@
   <p:cSld>
     <p:spTree>
       <p:nvGrpSpPr>
-        <p:cNvPr id="1" name=""/>
+        <p:cNvPr id="1" name="">
+          <a:extLst>
+            <a:ext uri="{FF2B5EF4-FFF2-40B4-BE49-F238E27FC236}">
+              <a16:creationId xmlns:a16="http://schemas.microsoft.com/office/drawing/2014/main" id="{B8E08838-7C9E-705D-2F7F-E838A017B8A4}"/>
+            </a:ext>
+          </a:extLst>
+        </p:cNvPr>
         <p:cNvGrpSpPr/>
         <p:nvPr/>
       </p:nvGrpSpPr>
@@ -22672,7 +22338,7 @@
           <p:cNvPr id="2" name="Title 1">
             <a:extLst>
               <a:ext uri="{FF2B5EF4-FFF2-40B4-BE49-F238E27FC236}">
-                <a16:creationId xmlns:a16="http://schemas.microsoft.com/office/drawing/2014/main" id="{2CD5A04A-5A2F-8442-99C4-2CA29AF20864}"/>
+                <a16:creationId xmlns:a16="http://schemas.microsoft.com/office/drawing/2014/main" id="{A497553C-DF2D-C952-7F23-00027AED17AB}"/>
               </a:ext>
             </a:extLst>
           </p:cNvPr>
@@ -22706,109 +22372,10 @@
       </p:sp>
       <p:sp>
         <p:nvSpPr>
-          <p:cNvPr id="3" name="Content Placeholder 2">
-            <a:extLst>
-              <a:ext uri="{FF2B5EF4-FFF2-40B4-BE49-F238E27FC236}">
-                <a16:creationId xmlns:a16="http://schemas.microsoft.com/office/drawing/2014/main" id="{60C7BC08-3A0C-FA40-A5E8-DD95B9AA8B13}"/>
-              </a:ext>
-            </a:extLst>
-          </p:cNvPr>
-          <p:cNvSpPr>
-            <a:spLocks noGrp="1"/>
-          </p:cNvSpPr>
-          <p:nvPr>
-            <p:ph idx="1"/>
-          </p:nvPr>
-        </p:nvSpPr>
-        <p:spPr>
-          <a:xfrm>
-            <a:off x="304800" y="2514600"/>
-            <a:ext cx="8305800" cy="3886199"/>
-          </a:xfrm>
-        </p:spPr>
-        <p:txBody>
-          <a:bodyPr/>
-          <a:lstStyle/>
-          <a:p>
-            <a:pPr marL="0" indent="0" algn="just">
-              <a:buNone/>
-            </a:pPr>
-            <a:r>
-              <a:rPr lang="en-US" dirty="0"/>
-              <a:t>So to prove that (2) is valid, given (1) from the previous slide, we only need to prove that when (2) terminates early because h becomes false, then it will also terminate in Q. In other words, we only need to prove:</a:t>
-            </a:r>
-          </a:p>
-          <a:p>
-            <a:pPr marL="0" indent="0" algn="just">
-              <a:buNone/>
-            </a:pPr>
-            <a:endParaRPr lang="en-US" dirty="0"/>
-          </a:p>
-          <a:p>
-            <a:pPr marL="0" indent="0" algn="just">
-              <a:buNone/>
-            </a:pPr>
-            <a:endParaRPr lang="en-US" dirty="0"/>
-          </a:p>
-          <a:p>
-            <a:pPr marL="0" indent="0" algn="just">
-              <a:buNone/>
-            </a:pPr>
-            <a:endParaRPr lang="en-US" dirty="0"/>
-          </a:p>
-          <a:p>
-            <a:pPr marL="0" indent="0" algn="just">
-              <a:buNone/>
-            </a:pPr>
-            <a:r>
-              <a:rPr lang="en-US" dirty="0"/>
-              <a:t>where I is the invariant used in (1).</a:t>
-            </a:r>
-          </a:p>
-          <a:p>
-            <a:pPr marL="0" indent="0" algn="just">
-              <a:buNone/>
-            </a:pPr>
-            <a:endParaRPr lang="en-US" dirty="0"/>
-          </a:p>
-          <a:p>
-            <a:pPr marL="344487" lvl="1" indent="0" algn="just">
-              <a:buNone/>
-            </a:pPr>
-            <a:endParaRPr lang="en-US" dirty="0"/>
-          </a:p>
-          <a:p>
-            <a:pPr marL="0" indent="0" algn="just">
-              <a:buNone/>
-            </a:pPr>
-            <a:endParaRPr lang="en-US" dirty="0"/>
-          </a:p>
-          <a:p>
-            <a:pPr marL="0" indent="0" algn="just">
-              <a:buNone/>
-            </a:pPr>
-            <a:endParaRPr lang="en-US" dirty="0"/>
-          </a:p>
-          <a:p>
-            <a:pPr marL="0" indent="0" algn="just">
-              <a:buNone/>
-            </a:pPr>
-            <a:endParaRPr lang="en-US" dirty="0"/>
-          </a:p>
-          <a:p>
-            <a:pPr marL="0" indent="0" algn="just">
-              <a:buNone/>
-            </a:pPr>
-            <a:endParaRPr lang="en-US" dirty="0"/>
-          </a:p>
-        </p:txBody>
-      </p:sp>
-      <p:sp>
-        <p:nvSpPr>
           <p:cNvPr id="4" name="Slide Number Placeholder 3">
             <a:extLst>
               <a:ext uri="{FF2B5EF4-FFF2-40B4-BE49-F238E27FC236}">
-                <a16:creationId xmlns:a16="http://schemas.microsoft.com/office/drawing/2014/main" id="{24FEC28F-DF61-C240-AD1D-163C675838F7}"/>
+                <a16:creationId xmlns:a16="http://schemas.microsoft.com/office/drawing/2014/main" id="{E76C4843-BB4B-CB6F-4F86-CD11600DE894}"/>
               </a:ext>
             </a:extLst>
           </p:cNvPr>
@@ -22840,10 +22407,10 @@
       </p:sp>
       <p:sp>
         <p:nvSpPr>
-          <p:cNvPr id="6" name="Rounded Rectangle 5">
+          <p:cNvPr id="5" name="Rounded Rectangle 4">
             <a:extLst>
               <a:ext uri="{FF2B5EF4-FFF2-40B4-BE49-F238E27FC236}">
-                <a16:creationId xmlns:a16="http://schemas.microsoft.com/office/drawing/2014/main" id="{E2995E38-D31E-1B44-B3B0-ABF876A42F83}"/>
+                <a16:creationId xmlns:a16="http://schemas.microsoft.com/office/drawing/2014/main" id="{F3537F26-655F-42B1-3794-031C11871196}"/>
               </a:ext>
             </a:extLst>
           </p:cNvPr>
@@ -22852,7 +22419,104 @@
         </p:nvSpPr>
         <p:spPr>
           <a:xfrm>
-            <a:off x="1981200" y="1371600"/>
+            <a:off x="990600" y="1219200"/>
+            <a:ext cx="5334000" cy="680710"/>
+          </a:xfrm>
+          <a:prstGeom prst="roundRect">
+            <a:avLst>
+              <a:gd name="adj" fmla="val 33084"/>
+            </a:avLst>
+          </a:prstGeom>
+          <a:solidFill>
+            <a:srgbClr val="FFC000">
+              <a:alpha val="25000"/>
+            </a:srgbClr>
+          </a:solidFill>
+          <a:ln>
+            <a:solidFill>
+              <a:srgbClr val="FFC000"/>
+            </a:solidFill>
+          </a:ln>
+        </p:spPr>
+        <p:style>
+          <a:lnRef idx="2">
+            <a:schemeClr val="accent1">
+              <a:shade val="50000"/>
+            </a:schemeClr>
+          </a:lnRef>
+          <a:fillRef idx="1">
+            <a:schemeClr val="accent1"/>
+          </a:fillRef>
+          <a:effectRef idx="0">
+            <a:schemeClr val="accent1"/>
+          </a:effectRef>
+          <a:fontRef idx="minor">
+            <a:schemeClr val="lt1"/>
+          </a:fontRef>
+        </p:style>
+        <p:txBody>
+          <a:bodyPr rtlCol="0" anchor="ctr"/>
+          <a:lstStyle/>
+          <a:p>
+            <a:pPr algn="ctr"/>
+            <a:r>
+              <a:rPr lang="en-US" sz="2400" dirty="0">
+                <a:solidFill>
+                  <a:schemeClr val="tx1"/>
+                </a:solidFill>
+              </a:rPr>
+              <a:t>{* P *}   </a:t>
+            </a:r>
+            <a:r>
+              <a:rPr lang="en-US" sz="2400" b="1" dirty="0">
+                <a:solidFill>
+                  <a:schemeClr val="tx1"/>
+                </a:solidFill>
+              </a:rPr>
+              <a:t>while</a:t>
+            </a:r>
+            <a:r>
+              <a:rPr lang="en-US" sz="2400" dirty="0">
+                <a:solidFill>
+                  <a:schemeClr val="tx1"/>
+                </a:solidFill>
+              </a:rPr>
+              <a:t> g </a:t>
+            </a:r>
+            <a:r>
+              <a:rPr lang="en-US" sz="2400" b="1" dirty="0">
+                <a:solidFill>
+                  <a:schemeClr val="tx1"/>
+                </a:solidFill>
+              </a:rPr>
+              <a:t>do</a:t>
+            </a:r>
+            <a:r>
+              <a:rPr lang="en-US" sz="2400" dirty="0">
+                <a:solidFill>
+                  <a:schemeClr val="tx1"/>
+                </a:solidFill>
+              </a:rPr>
+              <a:t> S   {* Q *}</a:t>
+            </a:r>
+          </a:p>
+        </p:txBody>
+      </p:sp>
+      <p:sp>
+        <p:nvSpPr>
+          <p:cNvPr id="6" name="Rounded Rectangle 5">
+            <a:extLst>
+              <a:ext uri="{FF2B5EF4-FFF2-40B4-BE49-F238E27FC236}">
+                <a16:creationId xmlns:a16="http://schemas.microsoft.com/office/drawing/2014/main" id="{7F0913E5-0F20-37FD-811E-C86BA0385A5A}"/>
+              </a:ext>
+            </a:extLst>
+          </p:cNvPr>
+          <p:cNvSpPr/>
+          <p:nvPr/>
+        </p:nvSpPr>
+        <p:spPr>
+          <a:xfrm>
+            <a:off x="967409" y="2209800"/>
             <a:ext cx="5334000" cy="609600"/>
           </a:xfrm>
           <a:prstGeom prst="roundRect">
@@ -22953,10 +22617,10 @@
       </p:sp>
       <p:sp>
         <p:nvSpPr>
-          <p:cNvPr id="9" name="TextBox 8">
+          <p:cNvPr id="8" name="TextBox 7">
             <a:extLst>
               <a:ext uri="{FF2B5EF4-FFF2-40B4-BE49-F238E27FC236}">
-                <a16:creationId xmlns:a16="http://schemas.microsoft.com/office/drawing/2014/main" id="{EC7039C8-5366-3244-B348-AEDFE7A72CC8}"/>
+                <a16:creationId xmlns:a16="http://schemas.microsoft.com/office/drawing/2014/main" id="{50EE503A-182B-8E58-5003-5F1D2C6B60DE}"/>
               </a:ext>
             </a:extLst>
           </p:cNvPr>
@@ -22965,7 +22629,7 @@
         </p:nvSpPr>
         <p:spPr>
           <a:xfrm>
-            <a:off x="1282485" y="1445567"/>
+            <a:off x="280734" y="1285208"/>
             <a:ext cx="561372" cy="461665"/>
           </a:xfrm>
           <a:prstGeom prst="rect">
@@ -22981,17 +22645,52 @@
           <a:p>
             <a:r>
               <a:rPr lang="en-US" sz="2400" dirty="0"/>
-              <a:t>(2)</a:t>
-            </a:r>
-          </a:p>
-        </p:txBody>
-      </p:sp>
-      <p:sp>
-        <p:nvSpPr>
-          <p:cNvPr id="10" name="Rounded Rectangle 9">
+              <a:t>(1)</a:t>
+            </a:r>
+          </a:p>
+        </p:txBody>
+      </p:sp>
+      <p:sp>
+        <p:nvSpPr>
+          <p:cNvPr id="9" name="TextBox 8">
             <a:extLst>
               <a:ext uri="{FF2B5EF4-FFF2-40B4-BE49-F238E27FC236}">
-                <a16:creationId xmlns:a16="http://schemas.microsoft.com/office/drawing/2014/main" id="{713E4141-4B8F-FE46-9184-02DC152498DB}"/>
+                <a16:creationId xmlns:a16="http://schemas.microsoft.com/office/drawing/2014/main" id="{1D1727FF-1EC9-C7D0-5F53-1A0F7F49CCF5}"/>
+              </a:ext>
+            </a:extLst>
+          </p:cNvPr>
+          <p:cNvSpPr txBox="1"/>
+          <p:nvPr/>
+        </p:nvSpPr>
+        <p:spPr>
+          <a:xfrm>
+            <a:off x="268694" y="2283767"/>
+            <a:ext cx="561372" cy="461665"/>
+          </a:xfrm>
+          <a:prstGeom prst="rect">
+            <a:avLst/>
+          </a:prstGeom>
+          <a:noFill/>
+        </p:spPr>
+        <p:txBody>
+          <a:bodyPr wrap="none" rtlCol="0">
+            <a:spAutoFit/>
+          </a:bodyPr>
+          <a:lstStyle/>
+          <a:p>
+            <a:r>
+              <a:rPr lang="en-US" sz="2400" dirty="0"/>
+              <a:t>(2)</a:t>
+            </a:r>
+          </a:p>
+        </p:txBody>
+      </p:sp>
+      <p:sp>
+        <p:nvSpPr>
+          <p:cNvPr id="11" name="Rounded Rectangle 10">
+            <a:extLst>
+              <a:ext uri="{FF2B5EF4-FFF2-40B4-BE49-F238E27FC236}">
+                <a16:creationId xmlns:a16="http://schemas.microsoft.com/office/drawing/2014/main" id="{238A75B4-0688-8DA1-FD51-F230D1D96D61}"/>
               </a:ext>
             </a:extLst>
           </p:cNvPr>
@@ -23000,12 +22699,12 @@
         </p:nvSpPr>
         <p:spPr>
           <a:xfrm>
-            <a:off x="3048000" y="4343400"/>
-            <a:ext cx="3200400" cy="609600"/>
+            <a:off x="6705600" y="1380842"/>
+            <a:ext cx="2247900" cy="1294364"/>
           </a:xfrm>
           <a:prstGeom prst="roundRect">
             <a:avLst>
-              <a:gd name="adj" fmla="val 33084"/>
+              <a:gd name="adj" fmla="val 19866"/>
             </a:avLst>
           </a:prstGeom>
           <a:solidFill>
@@ -23039,28 +22738,716 @@
           <a:bodyPr rtlCol="0" anchor="ctr"/>
           <a:lstStyle/>
           <a:p>
-            <a:pPr algn="ctr"/>
-            <a:r>
-              <a:rPr lang="en-US" sz="2400" dirty="0">
+            <a:r>
+              <a:rPr lang="en-US" sz="1000" dirty="0">
                 <a:solidFill>
                   <a:schemeClr val="tx1"/>
                 </a:solidFill>
               </a:rPr>
-              <a:t>I /\ g /\ ¬h  ⇒  Q</a:t>
-            </a:r>
+              <a:t>P </a:t>
+            </a:r>
+            <a:r>
+              <a:rPr lang="en-US" sz="1000" dirty="0">
+                <a:solidFill>
+                  <a:schemeClr val="tx1"/>
+                </a:solidFill>
+                <a:sym typeface="Symbol"/>
+              </a:rPr>
+              <a:t> I</a:t>
+            </a:r>
+            <a:br>
+              <a:rPr lang="en-US" sz="1000" dirty="0">
+                <a:solidFill>
+                  <a:schemeClr val="tx1"/>
+                </a:solidFill>
+                <a:sym typeface="Symbol"/>
+              </a:rPr>
+            </a:br>
+            <a:r>
+              <a:rPr lang="en-US" sz="1000" dirty="0">
+                <a:solidFill>
+                  <a:schemeClr val="tx1"/>
+                </a:solidFill>
+                <a:sym typeface="Symbol"/>
+              </a:rPr>
+              <a:t>{* g  /\  I *}    S    {*  I  *}</a:t>
+            </a:r>
+            <a:br>
+              <a:rPr lang="en-US" sz="1000" dirty="0">
+                <a:solidFill>
+                  <a:schemeClr val="tx1"/>
+                </a:solidFill>
+                <a:sym typeface="Symbol"/>
+              </a:rPr>
+            </a:br>
+            <a:r>
+              <a:rPr lang="en-US" sz="1000" dirty="0">
+                <a:solidFill>
+                  <a:schemeClr val="tx1"/>
+                </a:solidFill>
+                <a:sym typeface="Symbol"/>
+              </a:rPr>
+              <a:t>I  /\ g    Q </a:t>
+            </a:r>
+            <a:br>
+              <a:rPr lang="en-US" sz="1000" dirty="0">
+                <a:solidFill>
+                  <a:schemeClr val="tx1"/>
+                </a:solidFill>
+                <a:sym typeface="Symbol"/>
+              </a:rPr>
+            </a:br>
+            <a:r>
+              <a:rPr lang="en-US" sz="1000" dirty="0">
+                <a:solidFill>
+                  <a:schemeClr val="tx1"/>
+                </a:solidFill>
+                <a:sym typeface="Symbol"/>
+              </a:rPr>
+              <a:t>{* I /\ g *}    C:=m; S   {* m&lt;C *} </a:t>
+            </a:r>
+            <a:br>
+              <a:rPr lang="en-US" sz="1000" dirty="0">
+                <a:solidFill>
+                  <a:schemeClr val="tx1"/>
+                </a:solidFill>
+                <a:sym typeface="Symbol"/>
+              </a:rPr>
+            </a:br>
+            <a:r>
+              <a:rPr lang="en-US" sz="1000" dirty="0">
+                <a:solidFill>
+                  <a:schemeClr val="tx1"/>
+                </a:solidFill>
+                <a:sym typeface="Symbol"/>
+              </a:rPr>
+              <a:t>I /\ g   </a:t>
+            </a:r>
+            <a:r>
+              <a:rPr lang="en-US" sz="1000" dirty="0">
+                <a:solidFill>
+                  <a:schemeClr val="tx1"/>
+                </a:solidFill>
+              </a:rPr>
+              <a:t>m </a:t>
+            </a:r>
+            <a:r>
+              <a:rPr lang="en-US" sz="1000" dirty="0">
+                <a:solidFill>
+                  <a:schemeClr val="tx1"/>
+                </a:solidFill>
+                <a:sym typeface="Symbol"/>
+              </a:rPr>
+              <a:t>&gt; 0</a:t>
+            </a:r>
+            <a:br>
+              <a:rPr lang="en-US" sz="1000" dirty="0">
+                <a:solidFill>
+                  <a:schemeClr val="tx1"/>
+                </a:solidFill>
+                <a:sym typeface="Symbol"/>
+              </a:rPr>
+            </a:br>
+            <a:r>
+              <a:rPr lang="en-US" sz="1000" dirty="0">
+                <a:solidFill>
+                  <a:schemeClr val="tx1"/>
+                </a:solidFill>
+                <a:sym typeface="Symbol"/>
+              </a:rPr>
+              <a:t>----------------------------------------</a:t>
+            </a:r>
+            <a:br>
+              <a:rPr lang="en-US" sz="1000" dirty="0">
+                <a:solidFill>
+                  <a:schemeClr val="tx1"/>
+                </a:solidFill>
+                <a:sym typeface="Symbol"/>
+              </a:rPr>
+            </a:br>
+            <a:r>
+              <a:rPr lang="en-US" sz="1000" dirty="0">
+                <a:solidFill>
+                  <a:schemeClr val="tx1"/>
+                </a:solidFill>
+                <a:sym typeface="Symbol"/>
+              </a:rPr>
+              <a:t>{* P *}   </a:t>
+            </a:r>
+            <a:r>
+              <a:rPr lang="en-US" sz="1000" b="1" dirty="0">
+                <a:solidFill>
+                  <a:schemeClr val="tx1"/>
+                </a:solidFill>
+                <a:sym typeface="Symbol"/>
+              </a:rPr>
+              <a:t>while</a:t>
+            </a:r>
+            <a:r>
+              <a:rPr lang="en-US" sz="1000" dirty="0">
+                <a:solidFill>
+                  <a:schemeClr val="tx1"/>
+                </a:solidFill>
+                <a:sym typeface="Symbol"/>
+              </a:rPr>
+              <a:t>  g  </a:t>
+            </a:r>
+            <a:r>
+              <a:rPr lang="en-US" sz="1000" b="1" dirty="0">
+                <a:solidFill>
+                  <a:schemeClr val="tx1"/>
+                </a:solidFill>
+                <a:sym typeface="Symbol"/>
+              </a:rPr>
+              <a:t>do</a:t>
+            </a:r>
+            <a:r>
+              <a:rPr lang="en-US" sz="1000" dirty="0">
+                <a:solidFill>
+                  <a:schemeClr val="tx1"/>
+                </a:solidFill>
+                <a:sym typeface="Symbol"/>
+              </a:rPr>
+              <a:t>   S    {* Q *}</a:t>
+            </a:r>
+            <a:br>
+              <a:rPr lang="en-US" sz="1000" dirty="0">
+                <a:solidFill>
+                  <a:schemeClr val="tx1"/>
+                </a:solidFill>
+                <a:sym typeface="Symbol"/>
+              </a:rPr>
+            </a:br>
+            <a:endParaRPr lang="en-US" sz="1000" dirty="0">
+              <a:solidFill>
+                <a:schemeClr val="tx1"/>
+              </a:solidFill>
+            </a:endParaRPr>
+          </a:p>
+        </p:txBody>
+      </p:sp>
+      <p:sp>
+        <p:nvSpPr>
+          <p:cNvPr id="12" name="TextBox 11">
+            <a:extLst>
+              <a:ext uri="{FF2B5EF4-FFF2-40B4-BE49-F238E27FC236}">
+                <a16:creationId xmlns:a16="http://schemas.microsoft.com/office/drawing/2014/main" id="{85FA8D6B-14B2-FB79-1885-C9E10EBCCDDC}"/>
+              </a:ext>
+            </a:extLst>
+          </p:cNvPr>
+          <p:cNvSpPr txBox="1"/>
+          <p:nvPr/>
+        </p:nvSpPr>
+        <p:spPr>
+          <a:xfrm>
+            <a:off x="304800" y="3007363"/>
+            <a:ext cx="8686799" cy="3447098"/>
+          </a:xfrm>
+          <a:prstGeom prst="rect">
+            <a:avLst/>
+          </a:prstGeom>
+          <a:noFill/>
+        </p:spPr>
+        <p:txBody>
+          <a:bodyPr wrap="square" rtlCol="0">
+            <a:spAutoFit/>
+          </a:bodyPr>
+          <a:lstStyle/>
+          <a:p>
+            <a:r>
+              <a:rPr lang="en-US" b="1" dirty="0" err="1"/>
+              <a:t>Thm</a:t>
+            </a:r>
+            <a:r>
+              <a:rPr lang="en-US" b="1" dirty="0"/>
+              <a:t>.</a:t>
+            </a:r>
+            <a:r>
+              <a:rPr lang="en-US" dirty="0"/>
+              <a:t> If we have I and m satisfying the above rule for (1) and </a:t>
+            </a:r>
+            <a:r>
+              <a:rPr lang="en-US" b="1" dirty="0"/>
+              <a:t>I ∧</a:t>
+            </a:r>
+            <a:r>
+              <a:rPr lang="en-US" b="1" dirty="0">
+                <a:solidFill>
+                  <a:srgbClr val="C00000"/>
+                </a:solidFill>
+              </a:rPr>
+              <a:t> </a:t>
+            </a:r>
+            <a:r>
+              <a:rPr lang="en-US" b="1" dirty="0">
+                <a:solidFill>
+                  <a:srgbClr val="C00000"/>
+                </a:solidFill>
+                <a:sym typeface="Symbol"/>
+              </a:rPr>
+              <a:t></a:t>
+            </a:r>
+            <a:r>
+              <a:rPr lang="en-US" b="1" dirty="0">
+                <a:solidFill>
+                  <a:srgbClr val="C00000"/>
+                </a:solidFill>
+              </a:rPr>
+              <a:t> h</a:t>
+            </a:r>
+            <a:r>
+              <a:rPr lang="en-US" b="1" dirty="0">
+                <a:sym typeface="Symbol"/>
+              </a:rPr>
+              <a:t>   Q</a:t>
+            </a:r>
+            <a:r>
+              <a:rPr lang="en-US" dirty="0"/>
+              <a:t>, then I and m also satisfying the above for (2).</a:t>
+            </a:r>
+          </a:p>
+          <a:p>
+            <a:endParaRPr lang="en-US" sz="1400" dirty="0"/>
+          </a:p>
+          <a:p>
+            <a:r>
+              <a:rPr lang="en-US" sz="1400" i="1" dirty="0"/>
+              <a:t>Proof</a:t>
+            </a:r>
+            <a:r>
+              <a:rPr lang="en-US" sz="1400" dirty="0"/>
+              <a:t>. </a:t>
+            </a:r>
+          </a:p>
+          <a:p>
+            <a:pPr marL="342900" indent="-342900">
+              <a:buFont typeface="+mj-lt"/>
+              <a:buAutoNum type="arabicPeriod"/>
+            </a:pPr>
+            <a:r>
+              <a:rPr lang="en-US" sz="1400" dirty="0"/>
+              <a:t>P </a:t>
+            </a:r>
+            <a:r>
+              <a:rPr lang="en-US" sz="1400" dirty="0">
+                <a:sym typeface="Symbol"/>
+              </a:rPr>
+              <a:t> I. ✅</a:t>
+            </a:r>
+            <a:endParaRPr lang="en-US" sz="1400" b="1" dirty="0">
+              <a:sym typeface="Symbol"/>
+            </a:endParaRPr>
+          </a:p>
+          <a:p>
+            <a:pPr marL="342900" indent="-342900">
+              <a:buFont typeface="+mj-lt"/>
+              <a:buAutoNum type="arabicPeriod"/>
+            </a:pPr>
+            <a:r>
+              <a:rPr lang="en-US" sz="1400" dirty="0">
+                <a:sym typeface="Symbol"/>
+              </a:rPr>
+              <a:t>{* (</a:t>
+            </a:r>
+            <a:r>
+              <a:rPr lang="en-US" sz="1400" dirty="0"/>
+              <a:t>g </a:t>
+            </a:r>
+            <a:r>
+              <a:rPr lang="en-US" sz="1400" b="1" dirty="0">
+                <a:solidFill>
+                  <a:srgbClr val="C00000"/>
+                </a:solidFill>
+              </a:rPr>
+              <a:t>/\ h</a:t>
+            </a:r>
+            <a:r>
+              <a:rPr lang="en-US" sz="1400" dirty="0">
+                <a:sym typeface="Symbol"/>
+              </a:rPr>
+              <a:t>)  /\  I *}    S    {*  I  *} </a:t>
+            </a:r>
+          </a:p>
+          <a:p>
+            <a:pPr marL="800100" lvl="1" indent="-342900">
+              <a:buFont typeface="Arial" panose="020B0604020202020204" pitchFamily="34" charset="0"/>
+              <a:buChar char="•"/>
+            </a:pPr>
+            <a:r>
+              <a:rPr lang="en-US" sz="1400" dirty="0">
+                <a:sym typeface="Symbol"/>
+              </a:rPr>
+              <a:t>We know (</a:t>
+            </a:r>
+            <a:r>
+              <a:rPr lang="en-US" sz="1400" dirty="0"/>
+              <a:t>g </a:t>
+            </a:r>
+            <a:r>
+              <a:rPr lang="en-US" sz="1400" b="1" dirty="0">
+                <a:solidFill>
+                  <a:srgbClr val="C00000"/>
+                </a:solidFill>
+              </a:rPr>
+              <a:t>/\ h</a:t>
+            </a:r>
+            <a:r>
+              <a:rPr lang="en-US" sz="1400" dirty="0">
+                <a:sym typeface="Symbol"/>
+              </a:rPr>
+              <a:t>) /\  I  g  /\  I and {* g  /\  I *} S {*  I  *}, </a:t>
+            </a:r>
+            <a:br>
+              <a:rPr lang="en-US" sz="1400" dirty="0">
+                <a:sym typeface="Symbol"/>
+              </a:rPr>
+            </a:br>
+            <a:r>
+              <a:rPr lang="en-US" sz="1400" dirty="0">
+                <a:sym typeface="Symbol"/>
+              </a:rPr>
+              <a:t>so by precondition strengthening, we get the above.</a:t>
+            </a:r>
+          </a:p>
+          <a:p>
+            <a:pPr marL="342900" indent="-342900">
+              <a:buFont typeface="+mj-lt"/>
+              <a:buAutoNum type="arabicPeriod"/>
+            </a:pPr>
+            <a:r>
+              <a:rPr lang="en-US" sz="1400" dirty="0">
+                <a:sym typeface="Symbol"/>
+              </a:rPr>
+              <a:t>I  /\  (</a:t>
+            </a:r>
+            <a:r>
+              <a:rPr lang="en-US" sz="1400" dirty="0"/>
+              <a:t>g </a:t>
+            </a:r>
+            <a:r>
+              <a:rPr lang="en-US" sz="1400" dirty="0">
+                <a:solidFill>
+                  <a:srgbClr val="C00000"/>
+                </a:solidFill>
+              </a:rPr>
+              <a:t>/\ h</a:t>
+            </a:r>
+            <a:r>
+              <a:rPr lang="en-US" sz="1400" dirty="0">
+                <a:sym typeface="Symbol"/>
+              </a:rPr>
+              <a:t>)    Q </a:t>
+            </a:r>
+          </a:p>
+          <a:p>
+            <a:pPr marL="800100" lvl="1" indent="-342900">
+              <a:buFont typeface="Arial" panose="020B0604020202020204" pitchFamily="34" charset="0"/>
+              <a:buChar char="•"/>
+            </a:pPr>
+            <a:r>
+              <a:rPr lang="en-US" sz="1400" dirty="0">
+                <a:sym typeface="Symbol"/>
+              </a:rPr>
+              <a:t>This is equivalently (I  ∧  </a:t>
+            </a:r>
+            <a:r>
+              <a:rPr lang="en-US" sz="1400" dirty="0"/>
+              <a:t>g) ∨ (I ∧</a:t>
+            </a:r>
+            <a:r>
+              <a:rPr lang="en-US" sz="1400" dirty="0">
+                <a:solidFill>
+                  <a:srgbClr val="C00000"/>
+                </a:solidFill>
+              </a:rPr>
+              <a:t> </a:t>
+            </a:r>
+            <a:r>
+              <a:rPr lang="en-US" sz="1400" dirty="0">
+                <a:solidFill>
+                  <a:srgbClr val="C00000"/>
+                </a:solidFill>
+                <a:sym typeface="Symbol"/>
+              </a:rPr>
+              <a:t></a:t>
+            </a:r>
+            <a:r>
+              <a:rPr lang="en-US" sz="1400" dirty="0">
+                <a:solidFill>
+                  <a:srgbClr val="C00000"/>
+                </a:solidFill>
+              </a:rPr>
+              <a:t> h</a:t>
+            </a:r>
+            <a:r>
+              <a:rPr lang="en-US" sz="1400" dirty="0">
+                <a:sym typeface="Symbol"/>
+              </a:rPr>
+              <a:t>)   Q so we have to prove </a:t>
+            </a:r>
+            <a:br>
+              <a:rPr lang="en-US" sz="1400" dirty="0">
+                <a:sym typeface="Symbol"/>
+              </a:rPr>
+            </a:br>
+            <a:r>
+              <a:rPr lang="en-US" sz="1400" dirty="0">
+                <a:sym typeface="Symbol"/>
+              </a:rPr>
+              <a:t>I  ∧  </a:t>
+            </a:r>
+            <a:r>
+              <a:rPr lang="en-US" sz="1400" dirty="0"/>
+              <a:t>g </a:t>
+            </a:r>
+            <a:r>
+              <a:rPr lang="en-US" sz="1400" dirty="0">
+                <a:sym typeface="Symbol"/>
+              </a:rPr>
+              <a:t>  Q ✅  and</a:t>
+            </a:r>
+            <a:r>
+              <a:rPr lang="en-US" sz="1400" b="1" dirty="0">
+                <a:sym typeface="Symbol"/>
+              </a:rPr>
+              <a:t> </a:t>
+            </a:r>
+            <a:r>
+              <a:rPr lang="en-US" sz="1400" b="1" dirty="0"/>
+              <a:t>I ∧</a:t>
+            </a:r>
+            <a:r>
+              <a:rPr lang="en-US" sz="1400" b="1" dirty="0">
+                <a:solidFill>
+                  <a:srgbClr val="C00000"/>
+                </a:solidFill>
+              </a:rPr>
+              <a:t> </a:t>
+            </a:r>
+            <a:r>
+              <a:rPr lang="en-US" sz="1400" b="1" dirty="0">
+                <a:solidFill>
+                  <a:srgbClr val="C00000"/>
+                </a:solidFill>
+                <a:sym typeface="Symbol"/>
+              </a:rPr>
+              <a:t></a:t>
+            </a:r>
+            <a:r>
+              <a:rPr lang="en-US" sz="1400" b="1" dirty="0">
+                <a:solidFill>
+                  <a:srgbClr val="C00000"/>
+                </a:solidFill>
+              </a:rPr>
+              <a:t> h</a:t>
+            </a:r>
+            <a:r>
+              <a:rPr lang="en-US" sz="1400" b="1" dirty="0">
+                <a:sym typeface="Symbol"/>
+              </a:rPr>
+              <a:t>   Q </a:t>
+            </a:r>
+            <a:r>
+              <a:rPr lang="en-US" sz="1400" dirty="0">
+                <a:sym typeface="Symbol"/>
+              </a:rPr>
+              <a:t>✅</a:t>
+            </a:r>
+            <a:r>
+              <a:rPr lang="en-US" sz="1400" b="1" dirty="0">
+                <a:sym typeface="Symbol"/>
+              </a:rPr>
+              <a:t>.</a:t>
+            </a:r>
+            <a:endParaRPr lang="en-US" sz="1400" dirty="0">
+              <a:sym typeface="Symbol"/>
+            </a:endParaRPr>
+          </a:p>
+          <a:p>
+            <a:pPr marL="342900" indent="-342900">
+              <a:buFont typeface="+mj-lt"/>
+              <a:buAutoNum type="arabicPeriod"/>
+            </a:pPr>
+            <a:r>
+              <a:rPr lang="en-US" sz="1400" dirty="0">
+                <a:sym typeface="Symbol"/>
+              </a:rPr>
+              <a:t>{* I /\ (</a:t>
+            </a:r>
+            <a:r>
+              <a:rPr lang="en-US" sz="1400" dirty="0"/>
+              <a:t>g </a:t>
+            </a:r>
+            <a:r>
+              <a:rPr lang="en-US" sz="1400" b="1" dirty="0">
+                <a:solidFill>
+                  <a:srgbClr val="C00000"/>
+                </a:solidFill>
+              </a:rPr>
+              <a:t>/\ h</a:t>
+            </a:r>
+            <a:r>
+              <a:rPr lang="en-US" sz="1400" dirty="0">
+                <a:sym typeface="Symbol"/>
+              </a:rPr>
+              <a:t>) *}    C:=m; S   {* m&lt;C *} </a:t>
+            </a:r>
+          </a:p>
+          <a:p>
+            <a:pPr marL="800100" lvl="1" indent="-342900">
+              <a:buFont typeface="Arial" panose="020B0604020202020204" pitchFamily="34" charset="0"/>
+              <a:buChar char="•"/>
+            </a:pPr>
+            <a:r>
+              <a:rPr lang="en-US" sz="1400" dirty="0">
+                <a:sym typeface="Symbol"/>
+              </a:rPr>
+              <a:t>By precondition strengthening like 2.</a:t>
+            </a:r>
+          </a:p>
+          <a:p>
+            <a:pPr marL="342900" indent="-342900">
+              <a:buFont typeface="+mj-lt"/>
+              <a:buAutoNum type="arabicPeriod"/>
+            </a:pPr>
+            <a:r>
+              <a:rPr lang="en-US" sz="1400" dirty="0">
+                <a:sym typeface="Symbol"/>
+              </a:rPr>
+              <a:t>I /\ (</a:t>
+            </a:r>
+            <a:r>
+              <a:rPr lang="en-US" sz="1400" dirty="0"/>
+              <a:t>g </a:t>
+            </a:r>
+            <a:r>
+              <a:rPr lang="en-US" sz="1400" b="1" dirty="0">
+                <a:solidFill>
+                  <a:srgbClr val="C00000"/>
+                </a:solidFill>
+              </a:rPr>
+              <a:t>/\ h</a:t>
+            </a:r>
+            <a:r>
+              <a:rPr lang="en-US" sz="1400" dirty="0">
+                <a:sym typeface="Symbol"/>
+              </a:rPr>
+              <a:t>)   </a:t>
+            </a:r>
+            <a:r>
+              <a:rPr lang="en-US" sz="1400" dirty="0"/>
+              <a:t>m </a:t>
+            </a:r>
+            <a:r>
+              <a:rPr lang="en-US" sz="1400" dirty="0">
+                <a:sym typeface="Symbol"/>
+              </a:rPr>
+              <a:t>&gt; 0</a:t>
+            </a:r>
+          </a:p>
+          <a:p>
+            <a:pPr marL="800100" lvl="1" indent="-342900">
+              <a:buFont typeface="Arial" panose="020B0604020202020204" pitchFamily="34" charset="0"/>
+              <a:buChar char="•"/>
+            </a:pPr>
+            <a:r>
+              <a:rPr lang="en-US" sz="1400" dirty="0">
+                <a:sym typeface="Symbol"/>
+              </a:rPr>
+              <a:t>By strengthening.</a:t>
+            </a:r>
+            <a:endParaRPr lang="en-US" sz="1400" dirty="0"/>
           </a:p>
         </p:txBody>
       </p:sp>
     </p:spTree>
     <p:extLst>
       <p:ext uri="{BB962C8B-B14F-4D97-AF65-F5344CB8AC3E}">
-        <p14:creationId xmlns:p14="http://schemas.microsoft.com/office/powerpoint/2010/main" val="646753517"/>
+        <p14:creationId xmlns:p14="http://schemas.microsoft.com/office/powerpoint/2010/main" val="1646732757"/>
       </p:ext>
     </p:extLst>
   </p:cSld>
   <p:clrMapOvr>
     <a:masterClrMapping/>
   </p:clrMapOvr>
+  <p:timing>
+    <p:tnLst>
+      <p:par>
+        <p:cTn id="1" dur="indefinite" restart="never" nodeType="tmRoot">
+          <p:childTnLst>
+            <p:seq concurrent="1" nextAc="seek">
+              <p:cTn id="2" dur="indefinite" nodeType="mainSeq">
+                <p:childTnLst>
+                  <p:par>
+                    <p:cTn id="3" fill="hold">
+                      <p:stCondLst>
+                        <p:cond delay="indefinite"/>
+                      </p:stCondLst>
+                      <p:childTnLst>
+                        <p:par>
+                          <p:cTn id="4" fill="hold">
+                            <p:stCondLst>
+                              <p:cond delay="0"/>
+                            </p:stCondLst>
+                            <p:childTnLst>
+                              <p:par>
+                                <p:cTn id="5" presetID="1" presetClass="entr" presetSubtype="0" fill="hold" grpId="0" nodeType="clickEffect">
+                                  <p:stCondLst>
+                                    <p:cond delay="0"/>
+                                  </p:stCondLst>
+                                  <p:childTnLst>
+                                    <p:set>
+                                      <p:cBhvr>
+                                        <p:cTn id="6" dur="1" fill="hold">
+                                          <p:stCondLst>
+                                            <p:cond delay="0"/>
+                                          </p:stCondLst>
+                                        </p:cTn>
+                                        <p:tgtEl>
+                                          <p:spTgt spid="11"/>
+                                        </p:tgtEl>
+                                        <p:attrNameLst>
+                                          <p:attrName>style.visibility</p:attrName>
+                                        </p:attrNameLst>
+                                      </p:cBhvr>
+                                      <p:to>
+                                        <p:strVal val="visible"/>
+                                      </p:to>
+                                    </p:set>
+                                  </p:childTnLst>
+                                </p:cTn>
+                              </p:par>
+                            </p:childTnLst>
+                          </p:cTn>
+                        </p:par>
+                      </p:childTnLst>
+                    </p:cTn>
+                  </p:par>
+                </p:childTnLst>
+              </p:cTn>
+              <p:prevCondLst>
+                <p:cond evt="onPrev" delay="0">
+                  <p:tgtEl>
+                    <p:sldTgt/>
+                  </p:tgtEl>
+                </p:cond>
+              </p:prevCondLst>
+              <p:nextCondLst>
+                <p:cond evt="onNext" delay="0">
+                  <p:tgtEl>
+                    <p:sldTgt/>
+                  </p:tgtEl>
+                </p:cond>
+              </p:nextCondLst>
+            </p:seq>
+          </p:childTnLst>
+        </p:cTn>
+      </p:par>
+    </p:tnLst>
+    <p:bldLst>
+      <p:bldP spid="11" grpId="0" animBg="1"/>
+    </p:bldLst>
+  </p:timing>
 </p:sld>
 </file>
 
@@ -23586,6 +23973,64 @@
       </p:grpSpPr>
       <p:sp>
         <p:nvSpPr>
+          <p:cNvPr id="6" name="TextBox 5">
+            <a:extLst>
+              <a:ext uri="{FF2B5EF4-FFF2-40B4-BE49-F238E27FC236}">
+                <a16:creationId xmlns:a16="http://schemas.microsoft.com/office/drawing/2014/main" id="{35C17C38-4EFC-8CDA-6080-1A6C3D917344}"/>
+              </a:ext>
+            </a:extLst>
+          </p:cNvPr>
+          <p:cNvSpPr txBox="1"/>
+          <p:nvPr/>
+        </p:nvSpPr>
+        <p:spPr>
+          <a:xfrm>
+            <a:off x="4267200" y="2044184"/>
+            <a:ext cx="530915" cy="369332"/>
+          </a:xfrm>
+          <a:prstGeom prst="rect">
+            <a:avLst/>
+          </a:prstGeom>
+          <a:solidFill>
+            <a:schemeClr val="accent5">
+              <a:lumMod val="60000"/>
+              <a:lumOff val="40000"/>
+            </a:schemeClr>
+          </a:solidFill>
+        </p:spPr>
+        <p:txBody>
+          <a:bodyPr wrap="none" rtlCol="0">
+            <a:spAutoFit/>
+          </a:bodyPr>
+          <a:lstStyle/>
+          <a:p>
+            <a:r>
+              <a:rPr lang="nl-NL" b="1" dirty="0">
+                <a:solidFill>
+                  <a:srgbClr val="C00000"/>
+                </a:solidFill>
+              </a:rPr>
+              <a:t>/\  </a:t>
+            </a:r>
+            <a:r>
+              <a:rPr lang="nl-NL" b="1" dirty="0">
+                <a:solidFill>
+                  <a:srgbClr val="C00000"/>
+                </a:solidFill>
+                <a:sym typeface="Symbol"/>
+              </a:rPr>
+              <a:t>r</a:t>
+            </a:r>
+            <a:endParaRPr lang="en-US" b="1" dirty="0">
+              <a:solidFill>
+                <a:srgbClr val="C00000"/>
+              </a:solidFill>
+            </a:endParaRPr>
+          </a:p>
+        </p:txBody>
+      </p:sp>
+      <p:sp>
+        <p:nvSpPr>
           <p:cNvPr id="15" name="Rectangle 6"/>
           <p:cNvSpPr>
             <a:spLocks noGrp="1" noChangeArrowheads="1"/>
@@ -23690,8 +24135,8 @@
         </p:nvSpPr>
         <p:spPr bwMode="auto">
           <a:xfrm>
-            <a:off x="2286000" y="1676400"/>
-            <a:ext cx="4286751" cy="3785652"/>
+            <a:off x="3053481" y="1219200"/>
+            <a:ext cx="3265638" cy="2862322"/>
           </a:xfrm>
           <a:prstGeom prst="rect">
             <a:avLst/>
@@ -23711,54 +24156,54 @@
           <a:lstStyle/>
           <a:p>
             <a:r>
-              <a:rPr lang="en-US" sz="2400" dirty="0"/>
+              <a:rPr lang="en-US" dirty="0"/>
               <a:t>{* 0</a:t>
             </a:r>
             <a:r>
-              <a:rPr lang="en-US" sz="2400" dirty="0">
+              <a:rPr lang="en-US" dirty="0">
                 <a:sym typeface="Symbol" pitchFamily="16" charset="2"/>
               </a:rPr>
               <a:t>n</a:t>
             </a:r>
             <a:r>
-              <a:rPr lang="en-US" sz="2400" dirty="0"/>
+              <a:rPr lang="en-US" dirty="0"/>
               <a:t> *}   </a:t>
             </a:r>
             <a:br>
-              <a:rPr lang="en-US" sz="2400" dirty="0"/>
+              <a:rPr lang="en-US" dirty="0"/>
             </a:br>
             <a:br>
-              <a:rPr lang="en-US" sz="2400" dirty="0"/>
+              <a:rPr lang="en-US" dirty="0"/>
             </a:br>
             <a:r>
-              <a:rPr lang="en-US" sz="2400" dirty="0" err="1"/>
+              <a:rPr lang="en-US" dirty="0" err="1"/>
               <a:t>i</a:t>
             </a:r>
             <a:r>
-              <a:rPr lang="en-US" sz="2400" dirty="0"/>
+              <a:rPr lang="en-US" dirty="0"/>
               <a:t> := 0 ; r := true ;</a:t>
             </a:r>
             <a:br>
-              <a:rPr lang="en-US" sz="2400" dirty="0"/>
+              <a:rPr lang="en-US" dirty="0"/>
             </a:br>
             <a:r>
-              <a:rPr lang="en-US" sz="2400" b="1" dirty="0"/>
+              <a:rPr lang="en-US" b="1" dirty="0"/>
               <a:t>while</a:t>
             </a:r>
             <a:r>
-              <a:rPr lang="en-US" sz="2400" dirty="0"/>
+              <a:rPr lang="en-US" dirty="0"/>
               <a:t>  </a:t>
             </a:r>
             <a:r>
-              <a:rPr lang="en-US" sz="2400" dirty="0" err="1"/>
+              <a:rPr lang="en-US" dirty="0" err="1"/>
               <a:t>i</a:t>
             </a:r>
             <a:r>
-              <a:rPr lang="en-US" sz="2400" dirty="0"/>
+              <a:rPr lang="en-US" dirty="0"/>
               <a:t>&lt;n </a:t>
             </a:r>
             <a:r>
-              <a:rPr lang="en-US" sz="2400" dirty="0">
+              <a:rPr lang="en-US" dirty="0">
                 <a:solidFill>
                   <a:srgbClr val="C00000"/>
                 </a:solidFill>
@@ -23766,132 +24211,80 @@
               <a:t>    </a:t>
             </a:r>
             <a:r>
-              <a:rPr lang="en-US" sz="2400" dirty="0"/>
+              <a:rPr lang="en-US" dirty="0"/>
               <a:t>      </a:t>
             </a:r>
             <a:r>
-              <a:rPr lang="en-US" sz="2400" b="1" dirty="0"/>
+              <a:rPr lang="en-US" b="1" dirty="0"/>
               <a:t>do</a:t>
             </a:r>
             <a:r>
-              <a:rPr lang="en-US" sz="2400" dirty="0"/>
+              <a:rPr lang="en-US" dirty="0"/>
               <a:t>  { </a:t>
             </a:r>
           </a:p>
           <a:p>
             <a:r>
-              <a:rPr lang="en-US" sz="2400" dirty="0"/>
+              <a:rPr lang="en-US" dirty="0"/>
               <a:t>     r := r /\ (a[</a:t>
             </a:r>
             <a:r>
-              <a:rPr lang="en-US" sz="2400" dirty="0" err="1"/>
+              <a:rPr lang="en-US" dirty="0" err="1"/>
               <a:t>i</a:t>
             </a:r>
             <a:r>
-              <a:rPr lang="en-US" sz="2400" dirty="0"/>
+              <a:rPr lang="en-US" dirty="0"/>
               <a:t>]=0)  ;  </a:t>
             </a:r>
           </a:p>
           <a:p>
             <a:r>
-              <a:rPr lang="en-US" sz="2400" dirty="0"/>
+              <a:rPr lang="en-US" dirty="0"/>
               <a:t>     </a:t>
             </a:r>
             <a:r>
-              <a:rPr lang="en-US" sz="2400" dirty="0" err="1"/>
+              <a:rPr lang="en-US" dirty="0" err="1"/>
               <a:t>i</a:t>
             </a:r>
             <a:r>
-              <a:rPr lang="en-US" sz="2400" dirty="0"/>
+              <a:rPr lang="en-US" dirty="0"/>
               <a:t>++ </a:t>
             </a:r>
           </a:p>
           <a:p>
             <a:r>
-              <a:rPr lang="en-US" sz="2400" dirty="0"/>
+              <a:rPr lang="en-US" dirty="0"/>
               <a:t>}</a:t>
             </a:r>
             <a:br>
-              <a:rPr lang="en-US" sz="2400" dirty="0"/>
+              <a:rPr lang="en-US" dirty="0"/>
             </a:br>
             <a:br>
-              <a:rPr lang="en-US" sz="2400" dirty="0"/>
+              <a:rPr lang="en-US" dirty="0"/>
             </a:br>
             <a:r>
-              <a:rPr lang="en-US" sz="2400" dirty="0"/>
+              <a:rPr lang="en-US" dirty="0"/>
               <a:t>{*  r  = (</a:t>
             </a:r>
             <a:r>
-              <a:rPr lang="en-US" sz="2400" dirty="0">
+              <a:rPr lang="en-US" dirty="0">
                 <a:sym typeface="Symbol"/>
               </a:rPr>
               <a:t>k : 0k&lt;n : a[k]=0) </a:t>
             </a:r>
             <a:r>
-              <a:rPr lang="en-US" sz="2400" dirty="0">
+              <a:rPr lang="en-US" dirty="0">
                 <a:sym typeface="Symbol" pitchFamily="16" charset="2"/>
               </a:rPr>
               <a:t>*}</a:t>
             </a:r>
             <a:r>
-              <a:rPr lang="en-US" sz="2400" dirty="0"/>
+              <a:rPr lang="en-US" dirty="0"/>
               <a:t> </a:t>
             </a:r>
           </a:p>
           <a:p>
-            <a:endParaRPr lang="nl-NL" sz="2400" dirty="0"/>
-          </a:p>
-        </p:txBody>
-      </p:sp>
-      <p:sp>
-        <p:nvSpPr>
-          <p:cNvPr id="2" name="TextBox 1"/>
-          <p:cNvSpPr txBox="1"/>
-          <p:nvPr/>
-        </p:nvSpPr>
-        <p:spPr>
-          <a:xfrm>
-            <a:off x="3927272" y="2743200"/>
-            <a:ext cx="644728" cy="461665"/>
-          </a:xfrm>
-          <a:prstGeom prst="rect">
-            <a:avLst/>
-          </a:prstGeom>
-          <a:solidFill>
-            <a:schemeClr val="accent5">
-              <a:lumMod val="60000"/>
-              <a:lumOff val="40000"/>
-            </a:schemeClr>
-          </a:solidFill>
-        </p:spPr>
-        <p:txBody>
-          <a:bodyPr wrap="none" rtlCol="0">
-            <a:spAutoFit/>
-          </a:bodyPr>
-          <a:lstStyle/>
-          <a:p>
-            <a:r>
-              <a:rPr lang="nl-NL" sz="2400" b="1" dirty="0">
-                <a:solidFill>
-                  <a:srgbClr val="C00000"/>
-                </a:solidFill>
-              </a:rPr>
-              <a:t>/\  </a:t>
-            </a:r>
-            <a:r>
-              <a:rPr lang="nl-NL" sz="2400" b="1" dirty="0">
-                <a:solidFill>
-                  <a:srgbClr val="C00000"/>
-                </a:solidFill>
-                <a:sym typeface="Symbol"/>
-              </a:rPr>
-              <a:t>r</a:t>
-            </a:r>
-            <a:endParaRPr lang="en-US" sz="2400" b="1" dirty="0">
-              <a:solidFill>
-                <a:srgbClr val="C00000"/>
-              </a:solidFill>
-            </a:endParaRPr>
+            <a:endParaRPr lang="nl-NL" dirty="0"/>
           </a:p>
         </p:txBody>
       </p:sp>
@@ -23909,8 +24302,8 @@
         </p:nvSpPr>
         <p:spPr>
           <a:xfrm>
-            <a:off x="1981199" y="2362200"/>
-            <a:ext cx="4724401" cy="2057399"/>
+            <a:off x="2895598" y="1809209"/>
+            <a:ext cx="3352802" cy="1467392"/>
           </a:xfrm>
           <a:prstGeom prst="roundRect">
             <a:avLst>
@@ -23949,7 +24342,7 @@
           <a:lstStyle/>
           <a:p>
             <a:pPr algn="ctr"/>
-            <a:endParaRPr lang="en-US"/>
+            <a:endParaRPr lang="en-US" dirty="0"/>
           </a:p>
         </p:txBody>
       </p:sp>
@@ -23967,8 +24360,8 @@
         </p:nvSpPr>
         <p:spPr>
           <a:xfrm>
-            <a:off x="1981198" y="1676400"/>
-            <a:ext cx="4724401" cy="533400"/>
+            <a:off x="2895598" y="1209401"/>
+            <a:ext cx="3352802" cy="413260"/>
           </a:xfrm>
           <a:prstGeom prst="roundRect">
             <a:avLst>
@@ -24011,7 +24404,7 @@
           <a:lstStyle/>
           <a:p>
             <a:pPr algn="ctr"/>
-            <a:endParaRPr lang="en-US"/>
+            <a:endParaRPr lang="en-US" dirty="0"/>
           </a:p>
         </p:txBody>
       </p:sp>
@@ -24029,8 +24422,8 @@
         </p:nvSpPr>
         <p:spPr>
           <a:xfrm>
-            <a:off x="1981197" y="4571999"/>
-            <a:ext cx="4724401" cy="533400"/>
+            <a:off x="2895599" y="3390900"/>
+            <a:ext cx="3352802" cy="533400"/>
           </a:xfrm>
           <a:prstGeom prst="roundRect">
             <a:avLst>
@@ -24073,7 +24466,7 @@
           <a:lstStyle/>
           <a:p>
             <a:pPr algn="ctr"/>
-            <a:endParaRPr lang="en-US"/>
+            <a:endParaRPr lang="en-US" dirty="0"/>
           </a:p>
         </p:txBody>
       </p:sp>
@@ -24091,8 +24484,8 @@
         </p:nvSpPr>
         <p:spPr>
           <a:xfrm>
-            <a:off x="533400" y="5381387"/>
-            <a:ext cx="8305800" cy="646331"/>
+            <a:off x="496957" y="4038599"/>
+            <a:ext cx="8305800" cy="923330"/>
           </a:xfrm>
           <a:prstGeom prst="rect">
             <a:avLst/>
@@ -24105,10 +24498,264 @@
           </a:bodyPr>
           <a:lstStyle/>
           <a:p>
-            <a:pPr algn="ctr"/>
             <a:r>
               <a:rPr lang="en-US" dirty="0"/>
-              <a:t>We have proven the basic form of this program (without the break with /\ r) before. Now prove that with the break the program is still correct.</a:t>
+              <a:t>Without </a:t>
+            </a:r>
+            <a:r>
+              <a:rPr lang="nl-NL" b="1" dirty="0">
+                <a:solidFill>
+                  <a:srgbClr val="C00000"/>
+                </a:solidFill>
+              </a:rPr>
+              <a:t>/\  </a:t>
+            </a:r>
+            <a:r>
+              <a:rPr lang="nl-NL" b="1" dirty="0">
+                <a:solidFill>
+                  <a:srgbClr val="C00000"/>
+                </a:solidFill>
+                <a:sym typeface="Symbol"/>
+              </a:rPr>
+              <a:t>r</a:t>
+            </a:r>
+            <a:r>
+              <a:rPr lang="en-US" dirty="0"/>
+              <a:t>, we found </a:t>
+            </a:r>
+          </a:p>
+          <a:p>
+            <a:pPr marL="285750" indent="-285750">
+              <a:buFont typeface="Arial" panose="020B0604020202020204" pitchFamily="34" charset="0"/>
+              <a:buChar char="•"/>
+            </a:pPr>
+            <a:r>
+              <a:rPr lang="en-US" dirty="0"/>
+              <a:t>I = (r  = (</a:t>
+            </a:r>
+            <a:r>
+              <a:rPr lang="en-US" dirty="0">
+                <a:sym typeface="Symbol"/>
+              </a:rPr>
+              <a:t>k : 0k&lt;</a:t>
+            </a:r>
+            <a:r>
+              <a:rPr lang="en-US" dirty="0" err="1">
+                <a:sym typeface="Symbol"/>
+              </a:rPr>
+              <a:t>i</a:t>
+            </a:r>
+            <a:r>
+              <a:rPr lang="en-US" dirty="0">
+                <a:sym typeface="Symbol"/>
+              </a:rPr>
+              <a:t> : a[k]=0))   /\   0in</a:t>
+            </a:r>
+          </a:p>
+          <a:p>
+            <a:r>
+              <a:rPr lang="en-US" dirty="0">
+                <a:sym typeface="Symbol"/>
+              </a:rPr>
+              <a:t>We need to prove </a:t>
+            </a:r>
+            <a:r>
+              <a:rPr lang="en-US" b="1" dirty="0"/>
+              <a:t>I ∧</a:t>
+            </a:r>
+            <a:r>
+              <a:rPr lang="en-US" b="1" dirty="0">
+                <a:solidFill>
+                  <a:srgbClr val="C00000"/>
+                </a:solidFill>
+              </a:rPr>
+              <a:t> </a:t>
+            </a:r>
+            <a:r>
+              <a:rPr lang="en-US" b="1" dirty="0">
+                <a:solidFill>
+                  <a:srgbClr val="C00000"/>
+                </a:solidFill>
+                <a:sym typeface="Symbol"/>
+              </a:rPr>
+              <a:t></a:t>
+            </a:r>
+            <a:r>
+              <a:rPr lang="en-US" b="1" dirty="0">
+                <a:solidFill>
+                  <a:srgbClr val="C00000"/>
+                </a:solidFill>
+              </a:rPr>
+              <a:t> r</a:t>
+            </a:r>
+            <a:r>
+              <a:rPr lang="en-US" b="1" dirty="0">
+                <a:sym typeface="Symbol"/>
+              </a:rPr>
+              <a:t>   Q.</a:t>
+            </a:r>
+          </a:p>
+        </p:txBody>
+      </p:sp>
+      <p:sp>
+        <p:nvSpPr>
+          <p:cNvPr id="7" name="TextBox 6">
+            <a:extLst>
+              <a:ext uri="{FF2B5EF4-FFF2-40B4-BE49-F238E27FC236}">
+                <a16:creationId xmlns:a16="http://schemas.microsoft.com/office/drawing/2014/main" id="{6002F483-8319-086E-E44B-9F502DB18D68}"/>
+              </a:ext>
+            </a:extLst>
+          </p:cNvPr>
+          <p:cNvSpPr txBox="1"/>
+          <p:nvPr/>
+        </p:nvSpPr>
+        <p:spPr>
+          <a:xfrm>
+            <a:off x="496957" y="4965242"/>
+            <a:ext cx="8305800" cy="1815882"/>
+          </a:xfrm>
+          <a:prstGeom prst="rect">
+            <a:avLst/>
+          </a:prstGeom>
+          <a:noFill/>
+        </p:spPr>
+        <p:txBody>
+          <a:bodyPr wrap="square" rtlCol="0">
+            <a:spAutoFit/>
+          </a:bodyPr>
+          <a:lstStyle/>
+          <a:p>
+            <a:r>
+              <a:rPr lang="en-US" sz="1600" i="1" dirty="0"/>
+              <a:t>Proof</a:t>
+            </a:r>
+            <a:r>
+              <a:rPr lang="en-US" sz="1600" dirty="0"/>
+              <a:t>. Suppose (r  = (</a:t>
+            </a:r>
+            <a:r>
+              <a:rPr lang="en-US" sz="1600" dirty="0">
+                <a:sym typeface="Symbol"/>
+              </a:rPr>
+              <a:t>k : 0k&lt;</a:t>
+            </a:r>
+            <a:r>
+              <a:rPr lang="en-US" sz="1600" dirty="0" err="1">
+                <a:sym typeface="Symbol"/>
+              </a:rPr>
+              <a:t>i</a:t>
+            </a:r>
+            <a:r>
+              <a:rPr lang="en-US" sz="1600" dirty="0">
+                <a:sym typeface="Symbol"/>
+              </a:rPr>
+              <a:t> : a[k]=0))   /\   0in /\ ¬r. </a:t>
+            </a:r>
+            <a:r>
+              <a:rPr lang="en-US" sz="1600" dirty="0"/>
+              <a:t>We have</a:t>
+            </a:r>
+          </a:p>
+          <a:p>
+            <a:r>
+              <a:rPr lang="en-US" sz="1600" dirty="0">
+                <a:sym typeface="Symbol"/>
+              </a:rPr>
+              <a:t>	(k : 0k&lt;n : a[k]=0) = (k : 0k&lt;</a:t>
+            </a:r>
+            <a:r>
+              <a:rPr lang="en-US" sz="1600" dirty="0" err="1">
+                <a:sym typeface="Symbol"/>
+              </a:rPr>
+              <a:t>i</a:t>
+            </a:r>
+            <a:r>
+              <a:rPr lang="en-US" sz="1600" dirty="0">
+                <a:sym typeface="Symbol"/>
+              </a:rPr>
+              <a:t> : a[k]=0) ∧ (k : </a:t>
+            </a:r>
+            <a:r>
+              <a:rPr lang="en-US" sz="1600" dirty="0" err="1">
+                <a:sym typeface="Symbol"/>
+              </a:rPr>
+              <a:t>ik</a:t>
+            </a:r>
+            <a:r>
+              <a:rPr lang="en-US" sz="1600" dirty="0">
+                <a:sym typeface="Symbol"/>
+              </a:rPr>
+              <a:t>&lt;n : a[k]=0)</a:t>
+            </a:r>
+          </a:p>
+          <a:p>
+            <a:r>
+              <a:rPr lang="en-US" sz="1600" b="1" dirty="0">
+                <a:sym typeface="Symbol"/>
+              </a:rPr>
+              <a:t>                                                </a:t>
+            </a:r>
+            <a:r>
+              <a:rPr lang="en-US" sz="1600" dirty="0">
+                <a:sym typeface="Symbol"/>
+              </a:rPr>
+              <a:t>= r ∧ (k : </a:t>
+            </a:r>
+            <a:r>
+              <a:rPr lang="en-US" sz="1600" dirty="0" err="1">
+                <a:sym typeface="Symbol"/>
+              </a:rPr>
+              <a:t>ik</a:t>
+            </a:r>
+            <a:r>
+              <a:rPr lang="en-US" sz="1600" dirty="0">
+                <a:sym typeface="Symbol"/>
+              </a:rPr>
+              <a:t>&lt;n : a[k]=0)</a:t>
+            </a:r>
+          </a:p>
+          <a:p>
+            <a:r>
+              <a:rPr lang="en-US" sz="1600" dirty="0">
+                <a:sym typeface="Symbol"/>
+              </a:rPr>
+              <a:t>                                                = false ∧ (k : </a:t>
+            </a:r>
+            <a:r>
+              <a:rPr lang="en-US" sz="1600" dirty="0" err="1">
+                <a:sym typeface="Symbol"/>
+              </a:rPr>
+              <a:t>ik</a:t>
+            </a:r>
+            <a:r>
+              <a:rPr lang="en-US" sz="1600" dirty="0">
+                <a:sym typeface="Symbol"/>
+              </a:rPr>
+              <a:t>&lt;n : a[k]=0)</a:t>
+            </a:r>
+          </a:p>
+          <a:p>
+            <a:r>
+              <a:rPr lang="en-US" sz="1600" dirty="0">
+                <a:sym typeface="Symbol"/>
+              </a:rPr>
+              <a:t>                                                = false</a:t>
+            </a:r>
+          </a:p>
+          <a:p>
+            <a:r>
+              <a:rPr lang="en-US" sz="1600" dirty="0">
+                <a:sym typeface="Symbol"/>
+              </a:rPr>
+              <a:t>                                                = r.</a:t>
+            </a:r>
+          </a:p>
+          <a:p>
+            <a:r>
+              <a:rPr lang="en-US" sz="1600" dirty="0">
+                <a:sym typeface="Symbol"/>
+              </a:rPr>
+              <a:t>                                                </a:t>
             </a:r>
           </a:p>
         </p:txBody>
@@ -24123,6 +24770,84 @@
   <p:clrMapOvr>
     <a:masterClrMapping/>
   </p:clrMapOvr>
+  <p:timing>
+    <p:tnLst>
+      <p:par>
+        <p:cTn id="1" dur="indefinite" restart="never" nodeType="tmRoot">
+          <p:childTnLst>
+            <p:seq concurrent="1" nextAc="seek">
+              <p:cTn id="2" dur="indefinite" nodeType="mainSeq">
+                <p:childTnLst>
+                  <p:par>
+                    <p:cTn id="3" fill="hold">
+                      <p:stCondLst>
+                        <p:cond delay="indefinite"/>
+                      </p:stCondLst>
+                      <p:childTnLst>
+                        <p:par>
+                          <p:cTn id="4" fill="hold">
+                            <p:stCondLst>
+                              <p:cond delay="0"/>
+                            </p:stCondLst>
+                            <p:childTnLst>
+                              <p:par>
+                                <p:cTn id="5" presetID="1" presetClass="entr" presetSubtype="0" fill="hold" grpId="0" nodeType="clickEffect">
+                                  <p:stCondLst>
+                                    <p:cond delay="0"/>
+                                  </p:stCondLst>
+                                  <p:childTnLst>
+                                    <p:set>
+                                      <p:cBhvr>
+                                        <p:cTn id="6" dur="1" fill="hold">
+                                          <p:stCondLst>
+                                            <p:cond delay="0"/>
+                                          </p:stCondLst>
+                                        </p:cTn>
+                                        <p:tgtEl>
+                                          <p:spTgt spid="7"/>
+                                        </p:tgtEl>
+                                        <p:attrNameLst>
+                                          <p:attrName>style.visibility</p:attrName>
+                                        </p:attrNameLst>
+                                      </p:cBhvr>
+                                      <p:to>
+                                        <p:strVal val="visible"/>
+                                      </p:to>
+                                    </p:set>
+                                  </p:childTnLst>
+                                </p:cTn>
+                              </p:par>
+                            </p:childTnLst>
+                          </p:cTn>
+                        </p:par>
+                      </p:childTnLst>
+                    </p:cTn>
+                  </p:par>
+                </p:childTnLst>
+              </p:cTn>
+              <p:prevCondLst>
+                <p:cond evt="onPrev" delay="0">
+                  <p:tgtEl>
+                    <p:sldTgt/>
+                  </p:tgtEl>
+                </p:cond>
+              </p:prevCondLst>
+              <p:nextCondLst>
+                <p:cond evt="onNext" delay="0">
+                  <p:tgtEl>
+                    <p:sldTgt/>
+                  </p:tgtEl>
+                </p:cond>
+              </p:nextCondLst>
+            </p:seq>
+          </p:childTnLst>
+        </p:cTn>
+      </p:par>
+    </p:tnLst>
+    <p:bldLst>
+      <p:bldP spid="7" grpId="0"/>
+    </p:bldLst>
+  </p:timing>
 </p:sld>
 </file>
 
@@ -24426,7 +25151,7 @@
               <a:rPr lang="en-US" dirty="0">
                 <a:sym typeface="Wingdings"/>
               </a:rPr>
-              <a:t>, then assign these to </a:t>
+              <a:t>, then assigns these to </a:t>
             </a:r>
             <a:r>
               <a:rPr lang="en-US" i="1" dirty="0">
@@ -24450,7 +25175,19 @@
               <a:rPr lang="en-US" dirty="0">
                 <a:sym typeface="Wingdings"/>
               </a:rPr>
-              <a:t> respectively.</a:t>
+              <a:t> respectively and </a:t>
+            </a:r>
+            <a:r>
+              <a:rPr lang="en-US" b="1" dirty="0">
+                <a:sym typeface="Wingdings"/>
+              </a:rPr>
+              <a:t>simultaneously</a:t>
+            </a:r>
+            <a:r>
+              <a:rPr lang="en-US" dirty="0">
+                <a:sym typeface="Wingdings"/>
+              </a:rPr>
+              <a:t>.</a:t>
             </a:r>
           </a:p>
           <a:p>
@@ -28722,7 +29459,7 @@
           <a:p>
             <a:r>
               <a:rPr lang="en-US" dirty="0"/>
-              <a:t>Since we define our Hoare logic at the statement level, we first need to ”reduce” such a program-level specification to a specification in terms of its body.</a:t>
+              <a:t>Since we define our Hoare logic at the statement level, we first need to “reduce” such a program-level specification to a specification in terms of its body.</a:t>
             </a:r>
           </a:p>
           <a:p>
@@ -28735,7 +29472,7 @@
             <a:pPr lvl="1"/>
             <a:r>
               <a:rPr lang="en-US" dirty="0"/>
-              <a:t>What is the logic of a ”return” statement ?</a:t>
+              <a:t>What is the logic of a “return” statement ?</a:t>
             </a:r>
           </a:p>
           <a:p>
@@ -29741,7 +30478,7 @@
             </a:r>
             <a:r>
               <a:rPr lang="en-US" dirty="0"/>
-              <a:t>” (different variables pointing to the same data-cell). This complicate complicate the logic of assignment. Recall this logic:</a:t>
+              <a:t>” (different variables pointing to the same data-cell). This complicates the logic of assignment. Recall this logic:</a:t>
             </a:r>
             <a:br>
               <a:rPr lang="en-US" dirty="0"/>
@@ -29769,7 +30506,7 @@
           <a:p>
             <a:r>
               <a:rPr lang="en-US" dirty="0"/>
-              <a:t>Pass-by-copy-restore would still allow us to simulate programs with side effect, which is an interesting class to consider.</a:t>
+              <a:t>Pass-by-copy-restore still allows us to simulate programs with side effects, which is an interesting class to consider.</a:t>
             </a:r>
             <a:br>
               <a:rPr lang="en-US" dirty="0"/>
@@ -30106,7 +30843,7 @@
           <a:p>
             <a:r>
               <a:rPr lang="en-US" dirty="0"/>
-              <a:t>If ”x” is a pass-by-value parameter, in the post-condition it refers to its </a:t>
+              <a:t>If “x” is a pass-by-value parameter, in the post-condition it refers to its </a:t>
             </a:r>
             <a:r>
               <a:rPr lang="en-US" b="1" dirty="0"/>
@@ -33386,7 +34123,7 @@
             </a:pPr>
             <a:r>
               <a:rPr lang="en-US" sz="2400" dirty="0"/>
-              <a:t>represented by a graph. The program start in node 0, and 3 is the exit node. Each arrow represent an assignment to execute, guarded by the corresponding condition.</a:t>
+              <a:t>represented by a graph. The program starts in node 0, and 3 is the exit node. Each arrow represent an assignment to execute, guarded by the corresponding condition.</a:t>
             </a:r>
           </a:p>
           <a:p>
@@ -34610,7 +35347,15 @@
                 </a:r>
                 <a:r>
                   <a:rPr lang="en-US" dirty="0"/>
-                  <a:t> be the assertion at node s. Given a pre- and post-condition P and Q, they are valid if:</a:t>
+                  <a:t> be the assertion at node s. A pre- and post-condition P </a:t>
+                </a:r>
+                <a:r>
+                  <a:rPr lang="en-US"/>
+                  <a:t>and Q are </a:t>
+                </a:r>
+                <a:r>
+                  <a:rPr lang="en-US" dirty="0"/>
+                  <a:t>valid if:</a:t>
                 </a:r>
               </a:p>
               <a:p>
@@ -34773,7 +35518,7 @@
               <a:blipFill>
                 <a:blip r:embed="rId3"/>
                 <a:stretch>
-                  <a:fillRect l="-584" t="-515" b="-3093"/>
+                  <a:fillRect l="-583" t="-1031" b="-3093"/>
                 </a:stretch>
               </a:blipFill>
             </p:spPr>

</xml_diff>